<commit_message>
updated dorgau Liu gene list
</commit_message>
<xml_diff>
--- a/RO retinal gene heatmap.pptx
+++ b/RO retinal gene heatmap.pptx
@@ -3794,7 +3794,7 @@
         </p:blipFill>
         <p:spPr>
           <a:xfrm>
-            <a:off x="691536" y="0"/>
+            <a:off x="468184" y="0"/>
             <a:ext cx="2637693" cy="6858000"/>
           </a:xfrm>
           <a:prstGeom prst="rect">
@@ -3804,10 +3804,10 @@
       </p:pic>
       <p:pic>
         <p:nvPicPr>
-          <p:cNvPr id="12" name="Picture 11">
-            <a:extLst>
-              <a:ext uri="{FF2B5EF4-FFF2-40B4-BE49-F238E27FC236}">
-                <a16:creationId xmlns:a16="http://schemas.microsoft.com/office/drawing/2014/main" id="{B6D19133-6E46-84E1-64C9-C6B2EEBD774C}"/>
+          <p:cNvPr id="3" name="Picture 2">
+            <a:extLst>
+              <a:ext uri="{FF2B5EF4-FFF2-40B4-BE49-F238E27FC236}">
+                <a16:creationId xmlns:a16="http://schemas.microsoft.com/office/drawing/2014/main" id="{B7549D94-6977-D27C-EEF4-CCC8DE5C5DCD}"/>
               </a:ext>
             </a:extLst>
           </p:cNvPr>
@@ -3824,8 +3824,8 @@
         </p:blipFill>
         <p:spPr>
           <a:xfrm>
-            <a:off x="3619972" y="0"/>
-            <a:ext cx="2373923" cy="6858000"/>
+            <a:off x="9173963" y="0"/>
+            <a:ext cx="2857500" cy="6858000"/>
           </a:xfrm>
           <a:prstGeom prst="rect">
             <a:avLst/>
@@ -3834,10 +3834,10 @@
       </p:pic>
       <p:pic>
         <p:nvPicPr>
-          <p:cNvPr id="14" name="Picture 13">
-            <a:extLst>
-              <a:ext uri="{FF2B5EF4-FFF2-40B4-BE49-F238E27FC236}">
-                <a16:creationId xmlns:a16="http://schemas.microsoft.com/office/drawing/2014/main" id="{6F85CAC3-6A5C-0E48-8221-598B5A84815B}"/>
+          <p:cNvPr id="5" name="Picture 4">
+            <a:extLst>
+              <a:ext uri="{FF2B5EF4-FFF2-40B4-BE49-F238E27FC236}">
+                <a16:creationId xmlns:a16="http://schemas.microsoft.com/office/drawing/2014/main" id="{ACE70230-08D3-F50F-C97B-A35C7A3AA0DB}"/>
               </a:ext>
             </a:extLst>
           </p:cNvPr>
@@ -3854,14 +3854,80 @@
         </p:blipFill>
         <p:spPr>
           <a:xfrm>
-            <a:off x="6096000" y="0"/>
-            <a:ext cx="2637693" cy="6858000"/>
+            <a:off x="3055601" y="0"/>
+            <a:ext cx="2373923" cy="6858000"/>
           </a:xfrm>
           <a:prstGeom prst="rect">
             <a:avLst/>
           </a:prstGeom>
         </p:spPr>
       </p:pic>
+      <p:pic>
+        <p:nvPicPr>
+          <p:cNvPr id="7" name="Picture 6">
+            <a:extLst>
+              <a:ext uri="{FF2B5EF4-FFF2-40B4-BE49-F238E27FC236}">
+                <a16:creationId xmlns:a16="http://schemas.microsoft.com/office/drawing/2014/main" id="{95F0FCD9-1BB0-B3D6-598F-6D3C806B245C}"/>
+              </a:ext>
+            </a:extLst>
+          </p:cNvPr>
+          <p:cNvPicPr>
+            <a:picLocks noChangeAspect="1"/>
+          </p:cNvPicPr>
+          <p:nvPr/>
+        </p:nvPicPr>
+        <p:blipFill>
+          <a:blip r:embed="rId5"/>
+          <a:stretch>
+            <a:fillRect/>
+          </a:stretch>
+        </p:blipFill>
+        <p:spPr>
+          <a:xfrm>
+            <a:off x="6455125" y="0"/>
+            <a:ext cx="2637693" cy="6858000"/>
+          </a:xfrm>
+          <a:prstGeom prst="rect">
+            <a:avLst/>
+          </a:prstGeom>
+        </p:spPr>
+      </p:pic>
+      <p:cxnSp>
+        <p:nvCxnSpPr>
+          <p:cNvPr id="9" name="Straight Connector 8">
+            <a:extLst>
+              <a:ext uri="{FF2B5EF4-FFF2-40B4-BE49-F238E27FC236}">
+                <a16:creationId xmlns:a16="http://schemas.microsoft.com/office/drawing/2014/main" id="{255D5063-E487-9E74-1081-A30E115F4A97}"/>
+              </a:ext>
+            </a:extLst>
+          </p:cNvPr>
+          <p:cNvCxnSpPr/>
+          <p:nvPr/>
+        </p:nvCxnSpPr>
+        <p:spPr>
+          <a:xfrm>
+            <a:off x="6096000" y="10633"/>
+            <a:ext cx="0" cy="6868633"/>
+          </a:xfrm>
+          <a:prstGeom prst="line">
+            <a:avLst/>
+          </a:prstGeom>
+        </p:spPr>
+        <p:style>
+          <a:lnRef idx="2">
+            <a:schemeClr val="accent1"/>
+          </a:lnRef>
+          <a:fillRef idx="0">
+            <a:schemeClr val="accent1"/>
+          </a:fillRef>
+          <a:effectRef idx="1">
+            <a:schemeClr val="accent1"/>
+          </a:effectRef>
+          <a:fontRef idx="minor">
+            <a:schemeClr val="tx1"/>
+          </a:fontRef>
+        </p:style>
+      </p:cxnSp>
     </p:spTree>
     <p:extLst>
       <p:ext uri="{BB962C8B-B14F-4D97-AF65-F5344CB8AC3E}">
@@ -3914,7 +3980,7 @@
         </p:blipFill>
         <p:spPr>
           <a:xfrm>
-            <a:off x="460591" y="-19285"/>
+            <a:off x="0" y="-21643"/>
             <a:ext cx="7457924" cy="3389966"/>
           </a:xfrm>
           <a:prstGeom prst="rect">
@@ -3924,10 +3990,10 @@
       </p:pic>
       <p:pic>
         <p:nvPicPr>
-          <p:cNvPr id="5" name="Picture 4">
-            <a:extLst>
-              <a:ext uri="{FF2B5EF4-FFF2-40B4-BE49-F238E27FC236}">
-                <a16:creationId xmlns:a16="http://schemas.microsoft.com/office/drawing/2014/main" id="{6630437D-7837-93C8-E870-1CD7FE4195F6}"/>
+          <p:cNvPr id="4" name="Picture 3">
+            <a:extLst>
+              <a:ext uri="{FF2B5EF4-FFF2-40B4-BE49-F238E27FC236}">
+                <a16:creationId xmlns:a16="http://schemas.microsoft.com/office/drawing/2014/main" id="{EEE29A06-A6B5-557A-95AB-62ABE616261C}"/>
               </a:ext>
             </a:extLst>
           </p:cNvPr>
@@ -3944,8 +4010,8 @@
         </p:blipFill>
         <p:spPr>
           <a:xfrm>
-            <a:off x="460591" y="3389965"/>
-            <a:ext cx="7608753" cy="3458525"/>
+            <a:off x="0" y="3468035"/>
+            <a:ext cx="7457924" cy="3389966"/>
           </a:xfrm>
           <a:prstGeom prst="rect">
             <a:avLst/>
@@ -3954,10 +4020,10 @@
       </p:pic>
       <p:pic>
         <p:nvPicPr>
-          <p:cNvPr id="9" name="Picture 8">
-            <a:extLst>
-              <a:ext uri="{FF2B5EF4-FFF2-40B4-BE49-F238E27FC236}">
-                <a16:creationId xmlns:a16="http://schemas.microsoft.com/office/drawing/2014/main" id="{1008A6BE-0449-F6A3-AAA3-5279DD3DEC19}"/>
+          <p:cNvPr id="7" name="Picture 6">
+            <a:extLst>
+              <a:ext uri="{FF2B5EF4-FFF2-40B4-BE49-F238E27FC236}">
+                <a16:creationId xmlns:a16="http://schemas.microsoft.com/office/drawing/2014/main" id="{73AFE18C-B465-2C05-C268-D34B8E37394B}"/>
               </a:ext>
             </a:extLst>
           </p:cNvPr>
@@ -3974,14 +4040,80 @@
         </p:blipFill>
         <p:spPr>
           <a:xfrm>
-            <a:off x="8136998" y="143842"/>
-            <a:ext cx="4901937" cy="3063711"/>
+            <a:off x="7692271" y="3484416"/>
+            <a:ext cx="6072451" cy="3373584"/>
           </a:xfrm>
           <a:prstGeom prst="rect">
             <a:avLst/>
           </a:prstGeom>
         </p:spPr>
       </p:pic>
+      <p:pic>
+        <p:nvPicPr>
+          <p:cNvPr id="10" name="Picture 9">
+            <a:extLst>
+              <a:ext uri="{FF2B5EF4-FFF2-40B4-BE49-F238E27FC236}">
+                <a16:creationId xmlns:a16="http://schemas.microsoft.com/office/drawing/2014/main" id="{6B4D2F6E-6E35-1983-0D9E-C14C8DF2D4A3}"/>
+              </a:ext>
+            </a:extLst>
+          </p:cNvPr>
+          <p:cNvPicPr>
+            <a:picLocks noChangeAspect="1"/>
+          </p:cNvPicPr>
+          <p:nvPr/>
+        </p:nvPicPr>
+        <p:blipFill>
+          <a:blip r:embed="rId5"/>
+          <a:stretch>
+            <a:fillRect/>
+          </a:stretch>
+        </p:blipFill>
+        <p:spPr>
+          <a:xfrm>
+            <a:off x="7692271" y="114680"/>
+            <a:ext cx="5965776" cy="3314320"/>
+          </a:xfrm>
+          <a:prstGeom prst="rect">
+            <a:avLst/>
+          </a:prstGeom>
+        </p:spPr>
+      </p:pic>
+      <p:cxnSp>
+        <p:nvCxnSpPr>
+          <p:cNvPr id="11" name="Straight Connector 10">
+            <a:extLst>
+              <a:ext uri="{FF2B5EF4-FFF2-40B4-BE49-F238E27FC236}">
+                <a16:creationId xmlns:a16="http://schemas.microsoft.com/office/drawing/2014/main" id="{7E1C91FC-6A8E-A00A-9F05-E607F96B329A}"/>
+              </a:ext>
+            </a:extLst>
+          </p:cNvPr>
+          <p:cNvCxnSpPr/>
+          <p:nvPr/>
+        </p:nvCxnSpPr>
+        <p:spPr>
+          <a:xfrm>
+            <a:off x="7483062" y="-65994"/>
+            <a:ext cx="0" cy="6868633"/>
+          </a:xfrm>
+          <a:prstGeom prst="line">
+            <a:avLst/>
+          </a:prstGeom>
+        </p:spPr>
+        <p:style>
+          <a:lnRef idx="2">
+            <a:schemeClr val="accent1"/>
+          </a:lnRef>
+          <a:fillRef idx="0">
+            <a:schemeClr val="accent1"/>
+          </a:fillRef>
+          <a:effectRef idx="1">
+            <a:schemeClr val="accent1"/>
+          </a:effectRef>
+          <a:fontRef idx="minor">
+            <a:schemeClr val="tx1"/>
+          </a:fontRef>
+        </p:style>
+      </p:cxnSp>
     </p:spTree>
     <p:extLst>
       <p:ext uri="{BB962C8B-B14F-4D97-AF65-F5344CB8AC3E}">

</xml_diff>